<commit_message>
Align presentation and remove preprint footer
</commit_message>
<xml_diff>
--- a/docs/presentation/research_presentation.pptx
+++ b/docs/presentation/research_presentation.pptx
@@ -4008,7 +4008,7 @@
                           </a:solidFill>
                           <a:latin typeface="Aptos"/>
                         </a:rPr>
-                        <a:t>Learned two-item</a:t>
+                        <a:t>Linear two-item</a:t>
                       </a:r>
                     </a:p>
                   </a:txBody>
@@ -5432,7 +5432,7 @@
                 </a:solidFill>
                 <a:latin typeface="Aptos"/>
               </a:rPr>
-              <a:t>96%</a:t>
+              <a:t>95%</a:t>
             </a:r>
           </a:p>
         </p:txBody>
@@ -5547,7 +5547,7 @@
                 </a:solidFill>
                 <a:latin typeface="Aptos"/>
               </a:rPr>
-              <a:t>37%</a:t>
+              <a:t>39%</a:t>
             </a:r>
           </a:p>
         </p:txBody>
@@ -5662,7 +5662,7 @@
                 </a:solidFill>
                 <a:latin typeface="Aptos"/>
               </a:rPr>
-              <a:t>65%</a:t>
+              <a:t>71%</a:t>
             </a:r>
           </a:p>
         </p:txBody>
@@ -5697,7 +5697,7 @@
                 </a:solidFill>
                 <a:latin typeface="Aptos"/>
               </a:rPr>
-              <a:t>Learned two-item evidence is the better budgeted method: near-fixed accuracy at much lower evidence cost.</a:t>
+              <a:t>MLP+NMS evidence is the best learned budgeted method: near-fixed accuracy at much lower evidence cost.</a:t>
             </a:r>
           </a:p>
         </p:txBody>
@@ -6084,7 +6084,7 @@
                 </a:solidFill>
                 <a:latin typeface="Aptos"/>
               </a:rPr>
-              <a:t>The learned policy gives the best budgeted tradeoff: most of the high-cost answer accuracy, much lower evidence cost, and better grounding than one segment.</a:t>
+              <a:t>MLP+NMS gives the best learned budgeted tradeoff: most of the high-cost answer accuracy, much lower evidence cost, and better grounding than one segment.</a:t>
             </a:r>
           </a:p>
         </p:txBody>
@@ -7234,7 +7234,7 @@
                 </a:solidFill>
                 <a:latin typeface="Aptos"/>
               </a:rPr>
-              <a:t>Yes. Learned two-item evidence keeps about 96% of fixed 3+3 answer accuracy at 37% of the cost.</a:t>
+              <a:t>Yes. MLP+NMS evidence keeps about 95% of fixed 3+3 answer accuracy at 39% of the cost.</a:t>
             </a:r>
           </a:p>
         </p:txBody>
@@ -11794,7 +11794,7 @@
                           </a:solidFill>
                           <a:latin typeface="Aptos"/>
                         </a:rPr>
-                        <a:t>Learned two-item</a:t>
+                        <a:t>Linear two-item</a:t>
                       </a:r>
                     </a:p>
                   </a:txBody>
@@ -12243,7 +12243,7 @@
                 </a:solidFill>
                 <a:latin typeface="Aptos"/>
               </a:rPr>
-              <a:t>The learned linear router is trained from oracle traces; Qwen is not trained or used for routing.</a:t>
+              <a:t>The MLP router is trained from oracle traces; Qwen is not trained or used for routing.</a:t>
             </a:r>
           </a:p>
         </p:txBody>
@@ -13775,7 +13775,7 @@
                 </a:solidFill>
                 <a:latin typeface="Aptos"/>
               </a:rPr>
-              <a:t>Learned evidence gives the best cost-aware tradeoff.</a:t>
+              <a:t>MLP+NMS gives the best learned cost-aware tradeoff.</a:t>
             </a:r>
           </a:p>
         </p:txBody>

</xml_diff>